<commit_message>
Fit PowerPoint product screenshot within slide
</commit_message>
<xml_diff>
--- a/docs/site/路演.pptx
+++ b/docs/site/路演.pptx
@@ -6626,8 +6626,8 @@
         </p:blipFill>
         <p:spPr>
           <a:xfrm>
-            <a:off x="1975104" y="3017520"/>
-            <a:ext cx="8229600" cy="4732020"/>
+            <a:off x="3494888" y="3017520"/>
+            <a:ext cx="5201920" cy="2926080"/>
           </a:xfrm>
           <a:prstGeom prst="rect">
             <a:avLst/>

</xml_diff>